<commit_message>
Tighten spoken pitch copy in the deck for a clearer delivery.
</commit_message>
<xml_diff>
--- a/pitch/context-compiler-pitch.pptx
+++ b/pitch/context-compiler-pitch.pptx
@@ -3435,7 +3435,7 @@
                 </a:solidFill>
                 <a:latin typeface="Helvetica"/>
               </a:rPr>
-              <a:t>Give it a file, a question, and a token budget. It returns the useful parts as markdown, and a clear list of what it left out.</a:t>
+              <a:t>You give it a file, a question, and a token budget. You get the useful parts back as text, plus a clear list of what it skipped.</a:t>
             </a:r>
           </a:p>
         </p:txBody>
@@ -3562,7 +3562,7 @@
                 </a:solidFill>
                 <a:latin typeface="Helvetica"/>
               </a:rPr>
-              <a:t>One real handbook · one refunds question</a:t>
+              <a:t>One vendor handbook · one refunds question</a:t>
             </a:r>
           </a:p>
         </p:txBody>
@@ -4388,7 +4388,7 @@
                 </a:solidFill>
                 <a:latin typeface="Helvetica"/>
               </a:rPr>
-              <a:t>Agents often load an entire document to answer one question. Every time.</a:t>
+              <a:t>To answer one question, agents often load the entire document.</a:t>
             </a:r>
           </a:p>
         </p:txBody>
@@ -4560,7 +4560,7 @@
                 </a:solidFill>
                 <a:latin typeface="Helvetica"/>
               </a:rPr>
-              <a:t>Most of it is unused</a:t>
+              <a:t>Most of it never helps</a:t>
             </a:r>
           </a:p>
         </p:txBody>
@@ -4602,7 +4602,7 @@
                 </a:solidFill>
                 <a:latin typeface="Helvetica"/>
               </a:rPr>
-              <a:t>The useful clause might be 2 pages of 100. The other 98 are pure token spend.</a:t>
+              <a:t>Maybe 2 useful pages out of 100. The rest is pure spend.</a:t>
             </a:r>
           </a:p>
         </p:txBody>
@@ -4774,7 +4774,7 @@
                 </a:solidFill>
                 <a:latin typeface="Helvetica"/>
               </a:rPr>
-              <a:t>It adds up fast</a:t>
+              <a:t>Then it multiplies</a:t>
             </a:r>
           </a:p>
         </p:txBody>
@@ -4816,7 +4816,7 @@
                 </a:solidFill>
                 <a:latin typeface="Helvetica"/>
               </a:rPr>
-              <a:t>Every file × every question × every agent × every day. Cost and latency climb together.</a:t>
+              <a:t>Every file, every question, every agent, every day. Cost and latency climb together.</a:t>
             </a:r>
           </a:p>
         </p:txBody>
@@ -4943,7 +4943,7 @@
                 </a:solidFill>
                 <a:latin typeface="Helvetica"/>
               </a:rPr>
-              <a:t>per 1,000 reads of one 100-page document (at $3 per million input tokens; demo cost meter default)</a:t>
+              <a:t>per 1,000 reads of one 100-page document (at $3 per million input tokens; same default as the demo cost meter)</a:t>
             </a:r>
           </a:p>
         </p:txBody>
@@ -5115,7 +5115,7 @@
                 </a:solidFill>
                 <a:latin typeface="Helvetica"/>
               </a:rPr>
-              <a:t>of file tokens often unused for a single task, across pdf, docx, xlsx, pptx, and images</a:t>
+              <a:t>of the file’s tokens often unused for a single task (pdf, docx, xlsx, pptx, images)</a:t>
             </a:r>
           </a:p>
         </p:txBody>
@@ -5345,7 +5345,7 @@
                 </a:solidFill>
                 <a:latin typeface="Helvetica"/>
               </a:rPr>
-              <a:t>Plain version: who needs this, why we built it, what’s different, and how it sits next to converters.</a:t>
+              <a:t>Who needs this, why we built it, what’s different, and how it sits next to converters.</a:t>
             </a:r>
           </a:p>
         </p:txBody>
@@ -5517,7 +5517,7 @@
                 </a:solidFill>
                 <a:latin typeface="Helvetica"/>
               </a:rPr>
-              <a:t>People building coding and document agents. Cursor, Claude Code, Codex, and internal agent platforms.</a:t>
+              <a:t>People wiring coding agents and document agents. Cursor, Claude Code, Codex, internal platforms.</a:t>
             </a:r>
           </a:p>
         </p:txBody>
@@ -5689,7 +5689,7 @@
                 </a:solidFill>
                 <a:latin typeface="Helvetica"/>
               </a:rPr>
-              <a:t>Whole-file reads are getting expensive. Agents keep reopening the same manuals and reports for different questions.</a:t>
+              <a:t>Reading whole files is getting expensive. The same manuals and reports get reopened for different questions.</a:t>
             </a:r>
           </a:p>
         </p:txBody>
@@ -5816,7 +5816,7 @@
                 </a:solidFill>
                 <a:latin typeface="Helvetica"/>
               </a:rPr>
-              <a:t>One job. Pick what the agent needs under a hard token budget. Not a full search platform.</a:t>
+              <a:t>We do one job. Under a hard token budget, pick what the agent needs. We are not building a full search product.</a:t>
             </a:r>
           </a:p>
         </p:txBody>
@@ -5988,7 +5988,7 @@
                 </a:solidFill>
                 <a:latin typeface="Helvetica"/>
               </a:rPr>
-              <a:t>Converters turn a file into text of the whole thing. We select under a budget and tell you what was left out, so you can pull more if needed.</a:t>
+              <a:t>A converter gives you the whole file as text. We give you a budgeted slice, and we tell you what we left out so you can pull more if you need it.</a:t>
             </a:r>
           </a:p>
         </p:txBody>
@@ -6218,7 +6218,7 @@
                 </a:solidFill>
                 <a:latin typeface="Helvetica"/>
               </a:rPr>
-              <a:t>You set the ceiling. The agent gets markdown it can read, plus a list of skipped sections.</a:t>
+              <a:t>You set the ceiling. The agent gets readable text, plus a list of skipped sections.</a:t>
             </a:r>
           </a:p>
         </p:txBody>
@@ -6432,7 +6432,7 @@
                 </a:solidFill>
                 <a:latin typeface="Helvetica"/>
               </a:rPr>
-              <a:t>Turn the file into markdown. Cache by content so repeats are cheap.</a:t>
+              <a:t>Turn the file into text. Cache it so repeats are cheap.</a:t>
             </a:r>
           </a:p>
         </p:txBody>
@@ -6946,7 +6946,7 @@
                 </a:solidFill>
                 <a:latin typeface="Helvetica"/>
               </a:rPr>
-              <a:t>Match sections to the question on your machine. No model call to compile.</a:t>
+              <a:t>Match sections to the question on your machine. Compile does not call a model.</a:t>
             </a:r>
           </a:p>
         </p:txBody>
@@ -7203,7 +7203,7 @@
                 </a:solidFill>
                 <a:latin typeface="Helvetica"/>
               </a:rPr>
-              <a:t>Fill the strongest sections first until the question is covered, then stop.</a:t>
+              <a:t>Pack the strongest sections until the question is covered, then stop.</a:t>
             </a:r>
           </a:p>
         </p:txBody>
@@ -7375,7 +7375,7 @@
                 </a:solidFill>
                 <a:latin typeface="Helvetica"/>
               </a:rPr>
-              <a:t>Works with Cursor, Claude Code, Codex, and Claude Desktop. Or use the hosted web demo. Compile needs no API key.</a:t>
+              <a:t>Use it from Cursor, Claude Code, Codex, or Claude Desktop. Or try the web demo. Compile needs no API key.</a:t>
             </a:r>
           </a:p>
         </p:txBody>
@@ -7502,7 +7502,7 @@
                 </a:solidFill>
                 <a:latin typeface="Helvetica"/>
               </a:rPr>
-              <a:t>Every result lists what was left out. Open a skipped section when you need more of a chapter. Nothing is trimmed in silence.</a:t>
+              <a:t>Every result lists what was left out. Open a skipped section when you need more of a chapter. Nothing disappears quietly.</a:t>
             </a:r>
           </a:p>
         </p:txBody>
@@ -8032,7 +8032,7 @@
                 </a:solidFill>
                 <a:latin typeface="Helvetica"/>
               </a:rPr>
-              <a:t>cheaper per read when conversion is cached; repeats come back fast</a:t>
+              <a:t>cheaper per read once conversion is cached; repeats come back fast</a:t>
             </a:r>
           </a:p>
         </p:txBody>
@@ -8204,7 +8204,7 @@
                 </a:solidFill>
                 <a:latin typeface="Helvetica"/>
               </a:rPr>
-              <a:t>Same question from the full file and from the compiled slice. Compare the facts yourself.</a:t>
+              <a:t>Same question, full file vs compiled slice. You compare the facts. Not the same as letting the model browse on its own.</a:t>
             </a:r>
           </a:p>
         </p:txBody>
@@ -8459,7 +8459,7 @@
                 </a:solidFill>
                 <a:latin typeface="Helvetica"/>
               </a:rPr>
-              <a:t>Compiled: 591 tokens  ·  answer intact  ·  list of skipped sections included</a:t>
+              <a:t>Compiled: 591 tokens  ·  answer intact  ·  skipped sections listed</a:t>
             </a:r>
           </a:p>
         </p:txBody>
@@ -8947,7 +8947,7 @@
                 </a:solidFill>
                 <a:latin typeface="Helvetica"/>
               </a:rPr>
-              <a:t>Local embeddings next. Query cleanup and offline recall eval already shipped.</a:t>
+              <a:t>Local embeddings next. Cleanup and offline recall checks already shipped.</a:t>
             </a:r>
           </a:p>
         </p:txBody>
@@ -9161,7 +9161,7 @@
                 </a:solidFill>
                 <a:latin typeface="Helvetica"/>
               </a:rPr>
-              <a:t>Compile across a folder. Shared conversion cache for teams.</a:t>
+              <a:t>Compile across a folder of files. Shared conversion cache for teams.</a:t>
             </a:r>
           </a:p>
         </p:txBody>
@@ -9375,7 +9375,7 @@
                 </a:solidFill>
                 <a:latin typeface="Helvetica"/>
               </a:rPr>
-              <a:t>Transcribe into the same pipeline.</a:t>
+              <a:t>Transcribe, then run the same pipeline.</a:t>
             </a:r>
           </a:p>
         </p:txBody>
@@ -9589,7 +9589,7 @@
                 </a:solidFill>
                 <a:latin typeface="Helvetica"/>
               </a:rPr>
-              <a:t>Quick setup for any agent client that speaks the same protocol.</a:t>
+              <a:t>Quick setup for agent clients.</a:t>
             </a:r>
           </a:p>
         </p:txBody>

</xml_diff>